<commit_message>
feat: make DATA self-correction finish with green approval
</commit_message>
<xml_diff>
--- a/Fiducia_Pitch_Deck.pptx
+++ b/Fiducia_Pitch_Deck.pptx
@@ -9384,7 +9384,7 @@
                 </a:solidFill>
                 <a:latin typeface="DM Sans"/>
               </a:rPr>
-              <a:t>Run SUNX. Repair DATA. Open the governed human checkpoint.</a:t>
+              <a:t>Run DATA. Watch one bounded repair. Finish green.</a:t>
             </a:r>
           </a:p>
         </p:txBody>
@@ -10602,11 +10602,11 @@
             <a:avLst/>
           </a:prstGeom>
           <a:solidFill>
-            <a:srgbClr val="102D41"/>
+            <a:srgbClr val="0D282E"/>
           </a:solidFill>
           <a:ln w="12700">
             <a:solidFill>
-              <a:srgbClr val="19C6B3"/>
+              <a:srgbClr val="57D49B"/>
             </a:solidFill>
           </a:ln>
         </p:spPr>
@@ -10647,7 +10647,7 @@
             <a:avLst/>
           </a:prstGeom>
           <a:solidFill>
-            <a:srgbClr val="19C6B3"/>
+            <a:srgbClr val="57D49B"/>
           </a:solidFill>
           <a:ln>
             <a:noFill/>
@@ -10712,7 +10712,7 @@
                 </a:solidFill>
                 <a:latin typeface="DM Sans"/>
               </a:rPr>
-              <a:t>5</a:t>
+              <a:t>✓</a:t>
             </a:r>
           </a:p>
         </p:txBody>
@@ -10792,11 +10792,11 @@
             <a:r>
               <a:rPr sz="580" b="1">
                 <a:solidFill>
-                  <a:srgbClr val="19C6B3"/>
-                </a:solidFill>
-                <a:latin typeface="DM Sans"/>
-              </a:rPr>
-              <a:t>ACTIVE</a:t>
+                  <a:srgbClr val="57D49B"/>
+                </a:solidFill>
+                <a:latin typeface="DM Sans"/>
+              </a:rPr>
+              <a:t>COMPLETE</a:t>
             </a:r>
           </a:p>
         </p:txBody>
@@ -11284,7 +11284,7 @@
           </a:solidFill>
           <a:ln w="15240">
             <a:solidFill>
-              <a:srgbClr val="F4B942"/>
+              <a:srgbClr val="57D49B"/>
             </a:solidFill>
           </a:ln>
         </p:spPr>
@@ -11360,8 +11360,8 @@
         </p:nvSpPr>
         <p:spPr>
           <a:xfrm>
-            <a:off x="4151376" y="4050791"/>
-            <a:ext cx="3072384" cy="658368"/>
+            <a:off x="4151376" y="4142232"/>
+            <a:ext cx="3072384" cy="438912"/>
           </a:xfrm>
           <a:prstGeom prst="rect">
             <a:avLst/>
@@ -11383,14 +11383,13 @@
               </a:spcAft>
             </a:pPr>
             <a:r>
-              <a:rPr sz="2100" b="1">
-                <a:solidFill>
-                  <a:srgbClr val="F4B942"/>
+              <a:rPr sz="2500" b="1">
+                <a:solidFill>
+                  <a:srgbClr val="57D49B"/>
                 </a:solidFill>
                 <a:latin typeface="Manrope"/>
               </a:rPr>
-              <a:t>APPROVE WITH
-CONDITIONS</a:t>
+              <a:t>APPROVE</a:t>
             </a:r>
           </a:p>
         </p:txBody>
@@ -11432,7 +11431,7 @@
                 </a:solidFill>
                 <a:latin typeface="DM Sans"/>
               </a:rPr>
-              <a:t>Risk 4 / 100  •  Confidence 0.94</a:t>
+              <a:t>Risk 0 / 100  •  Confidence 0.94</a:t>
             </a:r>
           </a:p>
         </p:txBody>
@@ -11445,18 +11444,18 @@
         </p:nvSpPr>
         <p:spPr>
           <a:xfrm>
-            <a:off x="5952744" y="5010912"/>
-            <a:ext cx="1837943" cy="310896"/>
+            <a:off x="5797296" y="5010912"/>
+            <a:ext cx="1993392" cy="310896"/>
           </a:xfrm>
           <a:prstGeom prst="roundRect">
             <a:avLst/>
           </a:prstGeom>
           <a:solidFill>
-            <a:srgbClr val="2B2515"/>
+            <a:srgbClr val="0D282E"/>
           </a:solidFill>
           <a:ln w="12700">
             <a:solidFill>
-              <a:srgbClr val="765F2E"/>
+              <a:srgbClr val="2D6E62"/>
             </a:solidFill>
           </a:ln>
         </p:spPr>
@@ -11490,8 +11489,8 @@
         </p:nvSpPr>
         <p:spPr>
           <a:xfrm>
-            <a:off x="6025896" y="5015484"/>
-            <a:ext cx="1691639" cy="292608"/>
+            <a:off x="5870448" y="5015484"/>
+            <a:ext cx="1847088" cy="292608"/>
           </a:xfrm>
           <a:prstGeom prst="rect">
             <a:avLst/>
@@ -11513,13 +11512,13 @@
               </a:spcAft>
             </a:pPr>
             <a:r>
-              <a:rPr sz="700" b="1">
-                <a:solidFill>
-                  <a:srgbClr val="F4B942"/>
-                </a:solidFill>
-                <a:latin typeface="DM Sans"/>
-              </a:rPr>
-              <a:t>AWAITING HUMAN REVIEW</a:t>
+              <a:rPr sz="670" b="1">
+                <a:solidFill>
+                  <a:srgbClr val="57D49B"/>
+                </a:solidFill>
+                <a:latin typeface="DM Sans"/>
+              </a:rPr>
+              <a:t>COMPLETED · NO HUMAN TOUCH</a:t>
             </a:r>
           </a:p>
         </p:txBody>
@@ -12163,8 +12162,8 @@
                 </a:solidFill>
                 <a:latin typeface="DM Sans"/>
               </a:rPr>
-              <a:t>condition → pause
-reason required</a:t>
+              <a:t>SPECX → REJECT
+human checkpoint</a:t>
             </a:r>
           </a:p>
         </p:txBody>

</xml_diff>